<commit_message>
Rebase the course on rcapp2506/QC-2025-26 (v2.2 enhanced notebooks)
The base used so far (the 19 first-upload notebooks) was not the current course.
- qc-2025-26/: verbatim snapshot of https://github.com/rcapp2506/QC-2025-26
  (16 notebooks, Qiskit 2.x API); the old 19 move to archive/first-upload/.
- IBM/: the new notebooks renamed into a numbered study path
  (01 Bloch sphere ... 15 Shor generalized, 17 PENNY-QUANV); the enriched
  Shor notebook is kept as 16_Shor_Period_Finding_to_RSA (companion of lesson/).
- IQM/: 07_Running_on_Hardware and 16_Shor kept; the other editions will be
  re-backended next.
- lesson, deck (rebuilt, validated) and READMEs point to the new names.

Co-Authored-By: Claude Fable 5.1 <noreply@anthropic.com>
</commit_message>
<xml_diff>
--- a/lesson/RSA_Shor_lecture.pptx
+++ b/lesson/RSA_Shor_lecture.pptx
@@ -549,7 +549,7 @@
           <a:lstStyle/>
           <a:p>
             <a:r>
-              <a:t>Lecture for the Quantum Computing course (MSc Physics). Companion to lesson/rsa_shor_lesson.pdf and the shor.ipynb notebooks (IBM Aer / IQM).</a:t>
+              <a:t>Lecture for the Quantum Computing course (MSc Physics). Companion to lesson/rsa_shor_lesson.pdf and the 16_Shor_Period_Finding_to_RSA.ipynb notebooks (IBM Aer / IQM).</a:t>
             </a:r>
           </a:p>
         </p:txBody>
@@ -1599,7 +1599,7 @@
           <a:lstStyle/>
           <a:p>
             <a:r>
-              <a:t>End to end: from public data only, Shor recovers p and q, then phi, then d, then the message. This is the last section of shor.ipynb. N = 21 with a = 2 is the second worked example of the lesson.</a:t>
+              <a:t>End to end: from public data only, Shor recovers p and q, then phi, then d, then the message. This is the last section of 16_Shor_Period_Finding_to_RSA.ipynb. N = 21 with a = 2 is the second worked example of the lesson.</a:t>
             </a:r>
           </a:p>
         </p:txBody>
@@ -1879,7 +1879,7 @@
           <a:lstStyle/>
           <a:p>
             <a:r>
-              <a:t>Demo time. Each piece of the lecture is a named function in shor.ipynb. Run on the Aer simulator first; the IQM copy switches to Garnet/Emerald with the TARGET line.</a:t>
+              <a:t>Demo time. Each piece of the lecture is a named function in 16_Shor_Period_Finding_to_RSA.ipynb. Run on the Aer simulator first; the IQM copy switches to Garnet/Emerald with the TARGET line.</a:t>
             </a:r>
           </a:p>
         </p:txBody>
@@ -5869,7 +5869,7 @@
                   <a:srgbClr val="404040"/>
                 </a:solidFill>
               </a:rPr>
-              <a:t>Companion material: rsa_shor_lesson.pdf  ·  shor.ipynb (IBM Aer simulator / IQM Garnet &amp; Emerald)</a:t>
+              <a:t>Companion material: rsa_shor_lesson.pdf  ·  16_Shor_Period_Finding_to_RSA.ipynb (IBM Aer simulator / IQM Garnet &amp; Emerald)</a:t>
             </a:r>
           </a:p>
         </p:txBody>
@@ -8709,7 +8709,7 @@
                   <a:srgbClr val="404040"/>
                 </a:solidFill>
               </a:rPr>
-              <a:t>(RSA example.ipynb in the course repo)</a:t>
+              <a:t>(13_RSA.ipynb in the course repo)</a:t>
             </a:r>
           </a:p>
           <a:p>
@@ -13460,7 +13460,7 @@
                   <a:srgbClr val="404040"/>
                 </a:solidFill>
               </a:rPr>
-              <a:t>shor.ipynb: build_order_finding_circuit(a=7, n_count=4) for N = 15 — counting register on top, 4-qubit work register below</a:t>
+              <a:t>16_Shor_Period_Finding_to_RSA.ipynb: build_order_finding_circuit(a=7, n_count=4) for N = 15 — counting register on top, 4-qubit work register below</a:t>
             </a:r>
           </a:p>
         </p:txBody>
@@ -16343,7 +16343,7 @@
                   <a:srgbClr val="404040"/>
                 </a:solidFill>
               </a:rPr>
-              <a:t>IBM/shor.ipynb on the Aer simulator — 8 counting qubits, 2048 shots</a:t>
+              <a:t>IBM/16_Shor_Period_Finding_to_RSA.ipynb on the Aer simulator — 8 counting qubits, 2048 shots</a:t>
             </a:r>
           </a:p>
         </p:txBody>
@@ -17049,7 +17049,7 @@
                   <a:srgbClr val="404040"/>
                 </a:solidFill>
               </a:rPr>
-              <a:t>IQM/shor.ipynb on fake_apollo — IQM’s noisy model of a 20-qubit Garnet-class chip</a:t>
+              <a:t>IQM/16_Shor_Period_Finding_to_RSA.ipynb on fake_apollo — IQM’s noisy model of a 20-qubit Garnet-class chip</a:t>
             </a:r>
           </a:p>
         </p:txBody>
@@ -17292,7 +17292,7 @@
                   <a:srgbClr val="404040"/>
                 </a:solidFill>
               </a:rPr>
-              <a:t>One line selects the backend in IQM/shor.ipynb:  </a:t>
+              <a:t>One line selects the backend in IQM/16_Shor_Period_Finding_to_RSA.ipynb:  </a:t>
             </a:r>
             <a:r>
               <a:rPr sz="1500" b="1">
@@ -17546,7 +17546,7 @@
                   <a:srgbClr val="002060"/>
                 </a:solidFill>
               </a:rPr>
-              <a:t>The attack (shor.ipynb, last section)</a:t>
+              <a:t>The attack (16_Shor_Period_Finding_to_RSA.ipynb, last section)</a:t>
             </a:r>
           </a:p>
           <a:p>
@@ -19223,7 +19223,7 @@
                   <a:srgbClr val="0563C1"/>
                 </a:solidFill>
               </a:rPr>
-              <a:t>the machines behind IQM/shor.ipynb</a:t>
+              <a:t>the machines behind IQM/16_Shor_Period_Finding_to_RSA.ipynb</a:t>
             </a:r>
           </a:p>
         </p:txBody>
@@ -20233,7 +20233,7 @@
                             <a:srgbClr val="FFFFFF"/>
                           </a:solidFill>
                         </a:rPr>
-                        <a:t>shor.ipynb</a:t>
+                        <a:t>16_Shor_Period_Finding_to_RSA.ipynb</a:t>
                       </a:r>
                     </a:p>
                   </a:txBody>
@@ -20815,7 +20815,7 @@
                   <a:srgbClr val="404040"/>
                 </a:solidFill>
               </a:rPr>
-              <a:t>IBM/shor.ipynb: </a:t>
+              <a:t>IBM/16_Shor_Period_Finding_to_RSA.ipynb: </a:t>
             </a:r>
             <a:r>
               <a:rPr sz="1400">
@@ -20840,7 +20840,7 @@
                   <a:srgbClr val="404040"/>
                 </a:solidFill>
               </a:rPr>
-              <a:t>IQM/shor.ipynb: </a:t>
+              <a:t>IQM/16_Shor_Period_Finding_to_RSA.ipynb: </a:t>
             </a:r>
             <a:r>
               <a:rPr sz="1400">
@@ -22853,7 +22853,7 @@
                   <a:srgbClr val="0563C1"/>
                 </a:solidFill>
               </a:rPr>
-              <a:t>Thanks for your attention!   ·   rsa_shor_lesson.pdf · IBM/shor.ipynb · IQM/shor.ipynb</a:t>
+              <a:t>Thanks for your attention!   ·   rsa_shor_lesson.pdf · IBM/16_Shor_Period_Finding_to_RSA.ipynb · IQM/16_Shor_Period_Finding_to_RSA.ipynb</a:t>
             </a:r>
           </a:p>
         </p:txBody>

</xml_diff>